<commit_message>
Add combined workflow flowchart (detailed style + vertical language)
New 5th slide combines:
- Double-line borders (╔═══╗) from detailed flowchart
- Simpler, clearer language from vertical flowchart
- Shows all 4 phases with concise descriptions
- Output information for each phase
</commit_message>
<xml_diff>
--- a/presentation/test_workflow_flowcharts.pptx
+++ b/presentation/test_workflow_flowcharts.pptx
@@ -9,6 +9,7 @@
     <p:sldId id="257" r:id="rId8"/>
     <p:sldId id="258" r:id="rId9"/>
     <p:sldId id="259" r:id="rId10"/>
+    <p:sldId id="260" r:id="rId11"/>
   </p:sldIdLst>
   <p:sldSz cx="9144000" cy="6858000" type="screen4x3"/>
   <p:notesSz cx="6858000" cy="9144000"/>
@@ -5052,6 +5053,604 @@
             </a:pPr>
             <a:r>
               <a:t>OUTPUT: HTML report</a:t>
+            </a:r>
+          </a:p>
+        </p:txBody>
+      </p:sp>
+    </p:spTree>
+  </p:cSld>
+  <p:clrMapOvr>
+    <a:masterClrMapping/>
+  </p:clrMapOvr>
+</p:sld>
+</file>
+
+<file path=ppt/slides/slide5.xml><?xml version="1.0" encoding="utf-8"?>
+<p:sld xmlns:a="http://schemas.openxmlformats.org/drawingml/2006/main" xmlns:p="http://schemas.openxmlformats.org/presentationml/2006/main" xmlns:r="http://schemas.openxmlformats.org/officeDocument/2006/relationships">
+  <p:cSld>
+    <p:bg>
+      <p:bgPr>
+        <a:solidFill>
+          <a:srgbClr val="0D1117"/>
+        </a:solidFill>
+        <a:effectLst/>
+      </p:bgPr>
+    </p:bg>
+    <p:spTree>
+      <p:nvGrpSpPr>
+        <p:cNvPr id="1" name=""/>
+        <p:cNvGrpSpPr/>
+        <p:nvPr/>
+      </p:nvGrpSpPr>
+      <p:grpSpPr/>
+      <p:sp>
+        <p:nvSpPr>
+          <p:cNvPr id="2" name="TextBox 1"/>
+          <p:cNvSpPr txBox="1"/>
+          <p:nvPr/>
+        </p:nvSpPr>
+        <p:spPr>
+          <a:xfrm>
+            <a:off x="457200" y="274320"/>
+            <a:ext cx="8229600" cy="457200"/>
+          </a:xfrm>
+          <a:prstGeom prst="rect">
+            <a:avLst/>
+          </a:prstGeom>
+          <a:noFill/>
+        </p:spPr>
+        <p:txBody>
+          <a:bodyPr wrap="none">
+            <a:spAutoFit/>
+          </a:bodyPr>
+          <a:lstStyle/>
+          <a:p>
+            <a:pPr>
+              <a:defRPr sz="2400" b="1">
+                <a:solidFill>
+                  <a:srgbClr val="58A6FF"/>
+                </a:solidFill>
+                <a:latin typeface="Consolas"/>
+              </a:defRPr>
+            </a:pPr>
+            <a:r>
+              <a:t>$ cat workflow.txt</a:t>
+            </a:r>
+          </a:p>
+        </p:txBody>
+      </p:sp>
+      <p:sp>
+        <p:nvSpPr>
+          <p:cNvPr id="3" name="TextBox 2"/>
+          <p:cNvSpPr txBox="1"/>
+          <p:nvPr/>
+        </p:nvSpPr>
+        <p:spPr>
+          <a:xfrm>
+            <a:off x="1097280" y="1097280"/>
+            <a:ext cx="6949440" cy="5303520"/>
+          </a:xfrm>
+          <a:prstGeom prst="rect">
+            <a:avLst/>
+          </a:prstGeom>
+          <a:noFill/>
+        </p:spPr>
+        <p:txBody>
+          <a:bodyPr wrap="none">
+            <a:spAutoFit/>
+          </a:bodyPr>
+          <a:lstStyle/>
+          <a:p>
+            <a:pPr>
+              <a:lnSpc>
+                <a:spcPct val="100000"/>
+              </a:lnSpc>
+              <a:spcAft>
+                <a:spcPts val="200"/>
+              </a:spcAft>
+              <a:defRPr sz="1100">
+                <a:solidFill>
+                  <a:srgbClr val="C9D1D9"/>
+                </a:solidFill>
+                <a:latin typeface="Consolas"/>
+              </a:defRPr>
+            </a:pPr>
+            <a:r>
+              <a:t>water.xyz</a:t>
+            </a:r>
+          </a:p>
+          <a:p>
+            <a:pPr>
+              <a:lnSpc>
+                <a:spcPct val="100000"/>
+              </a:lnSpc>
+              <a:spcAft>
+                <a:spcPts val="200"/>
+              </a:spcAft>
+              <a:defRPr sz="1100">
+                <a:solidFill>
+                  <a:srgbClr val="8B949E"/>
+                </a:solidFill>
+                <a:latin typeface="Consolas"/>
+              </a:defRPr>
+            </a:pPr>
+            <a:r>
+              <a:t>    ↓</a:t>
+            </a:r>
+          </a:p>
+          <a:p>
+            <a:pPr>
+              <a:lnSpc>
+                <a:spcPct val="100000"/>
+              </a:lnSpc>
+              <a:spcAft>
+                <a:spcPts val="200"/>
+              </a:spcAft>
+              <a:defRPr sz="1100">
+                <a:solidFill>
+                  <a:srgbClr val="58A6FF"/>
+                </a:solidFill>
+                <a:latin typeface="Consolas"/>
+              </a:defRPr>
+            </a:pPr>
+            <a:r>
+              <a:t>╔═════════════════════════════════════════════════╗</a:t>
+            </a:r>
+          </a:p>
+          <a:p>
+            <a:pPr>
+              <a:lnSpc>
+                <a:spcPct val="100000"/>
+              </a:lnSpc>
+              <a:spcAft>
+                <a:spcPts val="200"/>
+              </a:spcAft>
+              <a:defRPr sz="1100">
+                <a:solidFill>
+                  <a:srgbClr val="58A6FF"/>
+                </a:solidFill>
+                <a:latin typeface="Consolas"/>
+              </a:defRPr>
+            </a:pPr>
+            <a:r>
+              <a:t>║  Phase 1: Geometry Optimization                ║</a:t>
+            </a:r>
+          </a:p>
+          <a:p>
+            <a:pPr>
+              <a:lnSpc>
+                <a:spcPct val="100000"/>
+              </a:lnSpc>
+              <a:spcAft>
+                <a:spcPts val="200"/>
+              </a:spcAft>
+              <a:defRPr sz="1100">
+                <a:solidFill>
+                  <a:srgbClr val="C9D1D9"/>
+                </a:solidFill>
+                <a:latin typeface="Consolas"/>
+              </a:defRPr>
+            </a:pPr>
+            <a:r>
+              <a:t>║  → MACE-OMOL calculator                         ║</a:t>
+            </a:r>
+          </a:p>
+          <a:p>
+            <a:pPr>
+              <a:lnSpc>
+                <a:spcPct val="100000"/>
+              </a:lnSpc>
+              <a:spcAft>
+                <a:spcPts val="200"/>
+              </a:spcAft>
+              <a:defRPr sz="1100">
+                <a:solidFill>
+                  <a:srgbClr val="C9D1D9"/>
+                </a:solidFill>
+                <a:latin typeface="Consolas"/>
+              </a:defRPr>
+            </a:pPr>
+            <a:r>
+              <a:t>║  → Output: optimized.xyz                        ║</a:t>
+            </a:r>
+          </a:p>
+          <a:p>
+            <a:pPr>
+              <a:lnSpc>
+                <a:spcPct val="100000"/>
+              </a:lnSpc>
+              <a:spcAft>
+                <a:spcPts val="200"/>
+              </a:spcAft>
+              <a:defRPr sz="1100">
+                <a:solidFill>
+                  <a:srgbClr val="58A6FF"/>
+                </a:solidFill>
+                <a:latin typeface="Consolas"/>
+              </a:defRPr>
+            </a:pPr>
+            <a:r>
+              <a:t>╚═════════════════════════════════════════════════╝</a:t>
+            </a:r>
+          </a:p>
+          <a:p>
+            <a:pPr>
+              <a:lnSpc>
+                <a:spcPct val="100000"/>
+              </a:lnSpc>
+              <a:spcAft>
+                <a:spcPts val="200"/>
+              </a:spcAft>
+              <a:defRPr sz="1100">
+                <a:solidFill>
+                  <a:srgbClr val="8B949E"/>
+                </a:solidFill>
+                <a:latin typeface="Consolas"/>
+              </a:defRPr>
+            </a:pPr>
+            <a:r>
+              <a:t>    ↓</a:t>
+            </a:r>
+          </a:p>
+          <a:p>
+            <a:pPr>
+              <a:lnSpc>
+                <a:spcPct val="100000"/>
+              </a:lnSpc>
+              <a:spcAft>
+                <a:spcPts val="200"/>
+              </a:spcAft>
+              <a:defRPr sz="1100">
+                <a:solidFill>
+                  <a:srgbClr val="58A6FF"/>
+                </a:solidFill>
+                <a:latin typeface="Consolas"/>
+              </a:defRPr>
+            </a:pPr>
+            <a:r>
+              <a:t>╔═════════════════════════════════════════════════╗</a:t>
+            </a:r>
+          </a:p>
+          <a:p>
+            <a:pPr>
+              <a:lnSpc>
+                <a:spcPct val="100000"/>
+              </a:lnSpc>
+              <a:spcAft>
+                <a:spcPts val="200"/>
+              </a:spcAft>
+              <a:defRPr sz="1100">
+                <a:solidFill>
+                  <a:srgbClr val="58A6FF"/>
+                </a:solidFill>
+                <a:latin typeface="Consolas"/>
+              </a:defRPr>
+            </a:pPr>
+            <a:r>
+              <a:t>║  Phase 2: DFT Baseline                          ║</a:t>
+            </a:r>
+          </a:p>
+          <a:p>
+            <a:pPr>
+              <a:lnSpc>
+                <a:spcPct val="100000"/>
+              </a:lnSpc>
+              <a:spcAft>
+                <a:spcPts val="200"/>
+              </a:spcAft>
+              <a:defRPr sz="1100">
+                <a:solidFill>
+                  <a:srgbClr val="C9D1D9"/>
+                </a:solidFill>
+                <a:latin typeface="Consolas"/>
+              </a:defRPr>
+            </a:pPr>
+            <a:r>
+              <a:t>║  → B3LYP/6-31G(d,p)                             ║</a:t>
+            </a:r>
+          </a:p>
+          <a:p>
+            <a:pPr>
+              <a:lnSpc>
+                <a:spcPct val="100000"/>
+              </a:lnSpc>
+              <a:spcAft>
+                <a:spcPts val="200"/>
+              </a:spcAft>
+              <a:defRPr sz="1100">
+                <a:solidFill>
+                  <a:srgbClr val="C9D1D9"/>
+                </a:solidFill>
+                <a:latin typeface="Consolas"/>
+              </a:defRPr>
+            </a:pPr>
+            <a:r>
+              <a:t>║  → Output: reference frequencies                ║</a:t>
+            </a:r>
+          </a:p>
+          <a:p>
+            <a:pPr>
+              <a:lnSpc>
+                <a:spcPct val="100000"/>
+              </a:lnSpc>
+              <a:spcAft>
+                <a:spcPts val="200"/>
+              </a:spcAft>
+              <a:defRPr sz="1100">
+                <a:solidFill>
+                  <a:srgbClr val="58A6FF"/>
+                </a:solidFill>
+                <a:latin typeface="Consolas"/>
+              </a:defRPr>
+            </a:pPr>
+            <a:r>
+              <a:t>╚═════════════════════════════════════════════════╝</a:t>
+            </a:r>
+          </a:p>
+          <a:p>
+            <a:pPr>
+              <a:lnSpc>
+                <a:spcPct val="100000"/>
+              </a:lnSpc>
+              <a:spcAft>
+                <a:spcPts val="200"/>
+              </a:spcAft>
+              <a:defRPr sz="1100">
+                <a:solidFill>
+                  <a:srgbClr val="8B949E"/>
+                </a:solidFill>
+                <a:latin typeface="Consolas"/>
+              </a:defRPr>
+            </a:pPr>
+            <a:r>
+              <a:t>    ↓</a:t>
+            </a:r>
+          </a:p>
+          <a:p>
+            <a:pPr>
+              <a:lnSpc>
+                <a:spcPct val="100000"/>
+              </a:lnSpc>
+              <a:spcAft>
+                <a:spcPts val="200"/>
+              </a:spcAft>
+              <a:defRPr sz="1100">
+                <a:solidFill>
+                  <a:srgbClr val="58A6FF"/>
+                </a:solidFill>
+                <a:latin typeface="Consolas"/>
+              </a:defRPr>
+            </a:pPr>
+            <a:r>
+              <a:t>╔═════════════════════════════════════════════════╗</a:t>
+            </a:r>
+          </a:p>
+          <a:p>
+            <a:pPr>
+              <a:lnSpc>
+                <a:spcPct val="100000"/>
+              </a:lnSpc>
+              <a:spcAft>
+                <a:spcPts val="200"/>
+              </a:spcAft>
+              <a:defRPr sz="1100">
+                <a:solidFill>
+                  <a:srgbClr val="58A6FF"/>
+                </a:solidFill>
+                <a:latin typeface="Consolas"/>
+              </a:defRPr>
+            </a:pPr>
+            <a:r>
+              <a:t>║  Phase 3: ML Frequency Calculations             ║</a:t>
+            </a:r>
+          </a:p>
+          <a:p>
+            <a:pPr>
+              <a:lnSpc>
+                <a:spcPct val="100000"/>
+              </a:lnSpc>
+              <a:spcAft>
+                <a:spcPts val="200"/>
+              </a:spcAft>
+              <a:defRPr sz="1100">
+                <a:solidFill>
+                  <a:srgbClr val="C9D1D9"/>
+                </a:solidFill>
+                <a:latin typeface="Consolas"/>
+              </a:defRPr>
+            </a:pPr>
+            <a:r>
+              <a:t>║  → Energy: MACE-MP/MACE-OMOL                    ║</a:t>
+            </a:r>
+          </a:p>
+          <a:p>
+            <a:pPr>
+              <a:lnSpc>
+                <a:spcPct val="100000"/>
+              </a:lnSpc>
+              <a:spcAft>
+                <a:spcPts val="200"/>
+              </a:spcAft>
+              <a:defRPr sz="1100">
+                <a:solidFill>
+                  <a:srgbClr val="C9D1D9"/>
+                </a:solidFill>
+                <a:latin typeface="Consolas"/>
+              </a:defRPr>
+            </a:pPr>
+            <a:r>
+              <a:t>║  → Dipole: Espaloma/MACE-ML                     ║</a:t>
+            </a:r>
+          </a:p>
+          <a:p>
+            <a:pPr>
+              <a:lnSpc>
+                <a:spcPct val="100000"/>
+              </a:lnSpc>
+              <a:spcAft>
+                <a:spcPts val="200"/>
+              </a:spcAft>
+              <a:defRPr sz="1100">
+                <a:solidFill>
+                  <a:srgbClr val="C9D1D9"/>
+                </a:solidFill>
+                <a:latin typeface="Consolas"/>
+              </a:defRPr>
+            </a:pPr>
+            <a:r>
+              <a:t>║  → ZMQ bridge → Gaussian                        ║</a:t>
+            </a:r>
+          </a:p>
+          <a:p>
+            <a:pPr>
+              <a:lnSpc>
+                <a:spcPct val="100000"/>
+              </a:lnSpc>
+              <a:spcAft>
+                <a:spcPts val="200"/>
+              </a:spcAft>
+              <a:defRPr sz="1100">
+                <a:solidFill>
+                  <a:srgbClr val="58A6FF"/>
+                </a:solidFill>
+                <a:latin typeface="Consolas"/>
+              </a:defRPr>
+            </a:pPr>
+            <a:r>
+              <a:t>╚═════════════════════════════════════════════════╝</a:t>
+            </a:r>
+          </a:p>
+          <a:p>
+            <a:pPr>
+              <a:lnSpc>
+                <a:spcPct val="100000"/>
+              </a:lnSpc>
+              <a:spcAft>
+                <a:spcPts val="200"/>
+              </a:spcAft>
+              <a:defRPr sz="1100">
+                <a:solidFill>
+                  <a:srgbClr val="8B949E"/>
+                </a:solidFill>
+                <a:latin typeface="Consolas"/>
+              </a:defRPr>
+            </a:pPr>
+            <a:r>
+              <a:t>    ↓</a:t>
+            </a:r>
+          </a:p>
+          <a:p>
+            <a:pPr>
+              <a:lnSpc>
+                <a:spcPct val="100000"/>
+              </a:lnSpc>
+              <a:spcAft>
+                <a:spcPts val="200"/>
+              </a:spcAft>
+              <a:defRPr sz="1100">
+                <a:solidFill>
+                  <a:srgbClr val="58A6FF"/>
+                </a:solidFill>
+                <a:latin typeface="Consolas"/>
+              </a:defRPr>
+            </a:pPr>
+            <a:r>
+              <a:t>╔═════════════════════════════════════════════════╗</a:t>
+            </a:r>
+          </a:p>
+          <a:p>
+            <a:pPr>
+              <a:lnSpc>
+                <a:spcPct val="100000"/>
+              </a:lnSpc>
+              <a:spcAft>
+                <a:spcPts val="200"/>
+              </a:spcAft>
+              <a:defRPr sz="1100">
+                <a:solidFill>
+                  <a:srgbClr val="58A6FF"/>
+                </a:solidFill>
+                <a:latin typeface="Consolas"/>
+              </a:defRPr>
+            </a:pPr>
+            <a:r>
+              <a:t>║  Phase 4: Analysis &amp; Comparison                 ║</a:t>
+            </a:r>
+          </a:p>
+          <a:p>
+            <a:pPr>
+              <a:lnSpc>
+                <a:spcPct val="100000"/>
+              </a:lnSpc>
+              <a:spcAft>
+                <a:spcPts val="200"/>
+              </a:spcAft>
+              <a:defRPr sz="1100">
+                <a:solidFill>
+                  <a:srgbClr val="C9D1D9"/>
+                </a:solidFill>
+                <a:latin typeface="Consolas"/>
+              </a:defRPr>
+            </a:pPr>
+            <a:r>
+              <a:t>║  → Statistics: MAE, RMSE, R²                    ║</a:t>
+            </a:r>
+          </a:p>
+          <a:p>
+            <a:pPr>
+              <a:lnSpc>
+                <a:spcPct val="100000"/>
+              </a:lnSpc>
+              <a:spcAft>
+                <a:spcPts val="200"/>
+              </a:spcAft>
+              <a:defRPr sz="1100">
+                <a:solidFill>
+                  <a:srgbClr val="C9D1D9"/>
+                </a:solidFill>
+                <a:latin typeface="Consolas"/>
+              </a:defRPr>
+            </a:pPr>
+            <a:r>
+              <a:t>║  → Plots: regression, spectra                   ║</a:t>
+            </a:r>
+          </a:p>
+          <a:p>
+            <a:pPr>
+              <a:lnSpc>
+                <a:spcPct val="100000"/>
+              </a:lnSpc>
+              <a:spcAft>
+                <a:spcPts val="200"/>
+              </a:spcAft>
+              <a:defRPr sz="1100">
+                <a:solidFill>
+                  <a:srgbClr val="C9D1D9"/>
+                </a:solidFill>
+                <a:latin typeface="Consolas"/>
+              </a:defRPr>
+            </a:pPr>
+            <a:r>
+              <a:t>║  → Output: HTML report                          ║</a:t>
+            </a:r>
+          </a:p>
+          <a:p>
+            <a:pPr>
+              <a:lnSpc>
+                <a:spcPct val="100000"/>
+              </a:lnSpc>
+              <a:spcAft>
+                <a:spcPts val="200"/>
+              </a:spcAft>
+              <a:defRPr sz="1100">
+                <a:solidFill>
+                  <a:srgbClr val="58A6FF"/>
+                </a:solidFill>
+                <a:latin typeface="Consolas"/>
+              </a:defRPr>
+            </a:pPr>
+            <a:r>
+              <a:t>╚═════════════════════════════════════════════════╝</a:t>
             </a:r>
           </a:p>
         </p:txBody>

</xml_diff>

<commit_message>
Add simple box workflow flowchart (single-line borders)
New 6th slide:
- Single-line box borders (┌─┐ └─┘) like MACE-Gaussian diagram
- Same simple style as architecture slide
- Vertical flow with all 4 phases
- Cleaner, more understated look
</commit_message>
<xml_diff>
--- a/presentation/test_workflow_flowcharts.pptx
+++ b/presentation/test_workflow_flowcharts.pptx
@@ -10,6 +10,7 @@
     <p:sldId id="258" r:id="rId9"/>
     <p:sldId id="259" r:id="rId10"/>
     <p:sldId id="260" r:id="rId11"/>
+    <p:sldId id="261" r:id="rId12"/>
   </p:sldIdLst>
   <p:sldSz cx="9144000" cy="6858000" type="screen4x3"/>
   <p:notesSz cx="6858000" cy="9144000"/>
@@ -5651,6 +5652,680 @@
             </a:pPr>
             <a:r>
               <a:t>╚═════════════════════════════════════════════════╝</a:t>
+            </a:r>
+          </a:p>
+        </p:txBody>
+      </p:sp>
+    </p:spTree>
+  </p:cSld>
+  <p:clrMapOvr>
+    <a:masterClrMapping/>
+  </p:clrMapOvr>
+</p:sld>
+</file>
+
+<file path=ppt/slides/slide6.xml><?xml version="1.0" encoding="utf-8"?>
+<p:sld xmlns:a="http://schemas.openxmlformats.org/drawingml/2006/main" xmlns:p="http://schemas.openxmlformats.org/presentationml/2006/main" xmlns:r="http://schemas.openxmlformats.org/officeDocument/2006/relationships">
+  <p:cSld>
+    <p:bg>
+      <p:bgPr>
+        <a:solidFill>
+          <a:srgbClr val="0D1117"/>
+        </a:solidFill>
+        <a:effectLst/>
+      </p:bgPr>
+    </p:bg>
+    <p:spTree>
+      <p:nvGrpSpPr>
+        <p:cNvPr id="1" name=""/>
+        <p:cNvGrpSpPr/>
+        <p:nvPr/>
+      </p:nvGrpSpPr>
+      <p:grpSpPr/>
+      <p:sp>
+        <p:nvSpPr>
+          <p:cNvPr id="2" name="TextBox 1"/>
+          <p:cNvSpPr txBox="1"/>
+          <p:nvPr/>
+        </p:nvSpPr>
+        <p:spPr>
+          <a:xfrm>
+            <a:off x="457200" y="274320"/>
+            <a:ext cx="8229600" cy="457200"/>
+          </a:xfrm>
+          <a:prstGeom prst="rect">
+            <a:avLst/>
+          </a:prstGeom>
+          <a:noFill/>
+        </p:spPr>
+        <p:txBody>
+          <a:bodyPr wrap="none">
+            <a:spAutoFit/>
+          </a:bodyPr>
+          <a:lstStyle/>
+          <a:p>
+            <a:pPr>
+              <a:defRPr sz="2400" b="1">
+                <a:solidFill>
+                  <a:srgbClr val="58A6FF"/>
+                </a:solidFill>
+                <a:latin typeface="Consolas"/>
+              </a:defRPr>
+            </a:pPr>
+            <a:r>
+              <a:t>$ cat workflow_simple.txt</a:t>
+            </a:r>
+          </a:p>
+        </p:txBody>
+      </p:sp>
+      <p:sp>
+        <p:nvSpPr>
+          <p:cNvPr id="3" name="TextBox 2"/>
+          <p:cNvSpPr txBox="1"/>
+          <p:nvPr/>
+        </p:nvSpPr>
+        <p:spPr>
+          <a:xfrm>
+            <a:off x="1097280" y="1097280"/>
+            <a:ext cx="6949440" cy="5303520"/>
+          </a:xfrm>
+          <a:prstGeom prst="rect">
+            <a:avLst/>
+          </a:prstGeom>
+          <a:noFill/>
+        </p:spPr>
+        <p:txBody>
+          <a:bodyPr wrap="none">
+            <a:spAutoFit/>
+          </a:bodyPr>
+          <a:lstStyle/>
+          <a:p>
+            <a:pPr>
+              <a:lnSpc>
+                <a:spcPct val="100000"/>
+              </a:lnSpc>
+              <a:spcAft>
+                <a:spcPts val="200"/>
+              </a:spcAft>
+              <a:defRPr sz="1100">
+                <a:solidFill>
+                  <a:srgbClr val="C9D1D9"/>
+                </a:solidFill>
+                <a:latin typeface="Consolas"/>
+              </a:defRPr>
+            </a:pPr>
+            <a:r>
+              <a:t>water.xyz</a:t>
+            </a:r>
+          </a:p>
+          <a:p>
+            <a:pPr>
+              <a:lnSpc>
+                <a:spcPct val="100000"/>
+              </a:lnSpc>
+              <a:spcAft>
+                <a:spcPts val="200"/>
+              </a:spcAft>
+              <a:defRPr sz="1100">
+                <a:solidFill>
+                  <a:srgbClr val="8B949E"/>
+                </a:solidFill>
+                <a:latin typeface="Consolas"/>
+              </a:defRPr>
+            </a:pPr>
+            <a:r>
+              <a:t>    │</a:t>
+            </a:r>
+          </a:p>
+          <a:p>
+            <a:pPr>
+              <a:lnSpc>
+                <a:spcPct val="100000"/>
+              </a:lnSpc>
+              <a:spcAft>
+                <a:spcPts val="200"/>
+              </a:spcAft>
+              <a:defRPr sz="1100">
+                <a:solidFill>
+                  <a:srgbClr val="8B949E"/>
+                </a:solidFill>
+                <a:latin typeface="Consolas"/>
+              </a:defRPr>
+            </a:pPr>
+            <a:r>
+              <a:t>    ▼</a:t>
+            </a:r>
+          </a:p>
+          <a:p>
+            <a:pPr>
+              <a:lnSpc>
+                <a:spcPct val="100000"/>
+              </a:lnSpc>
+              <a:spcAft>
+                <a:spcPts val="200"/>
+              </a:spcAft>
+              <a:defRPr sz="1100">
+                <a:solidFill>
+                  <a:srgbClr val="58A6FF"/>
+                </a:solidFill>
+                <a:latin typeface="Consolas"/>
+              </a:defRPr>
+            </a:pPr>
+            <a:r>
+              <a:t>┌─────────────────────────────────────────────────┐</a:t>
+            </a:r>
+          </a:p>
+          <a:p>
+            <a:pPr>
+              <a:lnSpc>
+                <a:spcPct val="100000"/>
+              </a:lnSpc>
+              <a:spcAft>
+                <a:spcPts val="200"/>
+              </a:spcAft>
+              <a:defRPr sz="1100">
+                <a:solidFill>
+                  <a:srgbClr val="58A6FF"/>
+                </a:solidFill>
+                <a:latin typeface="Consolas"/>
+              </a:defRPr>
+            </a:pPr>
+            <a:r>
+              <a:t>│  Phase 1: Geometry Optimization                 │</a:t>
+            </a:r>
+          </a:p>
+          <a:p>
+            <a:pPr>
+              <a:lnSpc>
+                <a:spcPct val="100000"/>
+              </a:lnSpc>
+              <a:spcAft>
+                <a:spcPts val="200"/>
+              </a:spcAft>
+              <a:defRPr sz="1100">
+                <a:solidFill>
+                  <a:srgbClr val="C9D1D9"/>
+                </a:solidFill>
+                <a:latin typeface="Consolas"/>
+              </a:defRPr>
+            </a:pPr>
+            <a:r>
+              <a:t>│  → MACE-OMOL calculator                         │</a:t>
+            </a:r>
+          </a:p>
+          <a:p>
+            <a:pPr>
+              <a:lnSpc>
+                <a:spcPct val="100000"/>
+              </a:lnSpc>
+              <a:spcAft>
+                <a:spcPts val="200"/>
+              </a:spcAft>
+              <a:defRPr sz="1100">
+                <a:solidFill>
+                  <a:srgbClr val="C9D1D9"/>
+                </a:solidFill>
+                <a:latin typeface="Consolas"/>
+              </a:defRPr>
+            </a:pPr>
+            <a:r>
+              <a:t>│  → Output: optimized.xyz                        │</a:t>
+            </a:r>
+          </a:p>
+          <a:p>
+            <a:pPr>
+              <a:lnSpc>
+                <a:spcPct val="100000"/>
+              </a:lnSpc>
+              <a:spcAft>
+                <a:spcPts val="200"/>
+              </a:spcAft>
+              <a:defRPr sz="1100">
+                <a:solidFill>
+                  <a:srgbClr val="58A6FF"/>
+                </a:solidFill>
+                <a:latin typeface="Consolas"/>
+              </a:defRPr>
+            </a:pPr>
+            <a:r>
+              <a:t>└─────────────────────────────────────────────────┘</a:t>
+            </a:r>
+          </a:p>
+          <a:p>
+            <a:pPr>
+              <a:lnSpc>
+                <a:spcPct val="100000"/>
+              </a:lnSpc>
+              <a:spcAft>
+                <a:spcPts val="200"/>
+              </a:spcAft>
+              <a:defRPr sz="1100">
+                <a:solidFill>
+                  <a:srgbClr val="8B949E"/>
+                </a:solidFill>
+                <a:latin typeface="Consolas"/>
+              </a:defRPr>
+            </a:pPr>
+            <a:r>
+              <a:t>    │</a:t>
+            </a:r>
+          </a:p>
+          <a:p>
+            <a:pPr>
+              <a:lnSpc>
+                <a:spcPct val="100000"/>
+              </a:lnSpc>
+              <a:spcAft>
+                <a:spcPts val="200"/>
+              </a:spcAft>
+              <a:defRPr sz="1100">
+                <a:solidFill>
+                  <a:srgbClr val="8B949E"/>
+                </a:solidFill>
+                <a:latin typeface="Consolas"/>
+              </a:defRPr>
+            </a:pPr>
+            <a:r>
+              <a:t>    ▼</a:t>
+            </a:r>
+          </a:p>
+          <a:p>
+            <a:pPr>
+              <a:lnSpc>
+                <a:spcPct val="100000"/>
+              </a:lnSpc>
+              <a:spcAft>
+                <a:spcPts val="200"/>
+              </a:spcAft>
+              <a:defRPr sz="1100">
+                <a:solidFill>
+                  <a:srgbClr val="58A6FF"/>
+                </a:solidFill>
+                <a:latin typeface="Consolas"/>
+              </a:defRPr>
+            </a:pPr>
+            <a:r>
+              <a:t>┌─────────────────────────────────────────────────┐</a:t>
+            </a:r>
+          </a:p>
+          <a:p>
+            <a:pPr>
+              <a:lnSpc>
+                <a:spcPct val="100000"/>
+              </a:lnSpc>
+              <a:spcAft>
+                <a:spcPts val="200"/>
+              </a:spcAft>
+              <a:defRPr sz="1100">
+                <a:solidFill>
+                  <a:srgbClr val="58A6FF"/>
+                </a:solidFill>
+                <a:latin typeface="Consolas"/>
+              </a:defRPr>
+            </a:pPr>
+            <a:r>
+              <a:t>│  Phase 2: DFT Baseline                          │</a:t>
+            </a:r>
+          </a:p>
+          <a:p>
+            <a:pPr>
+              <a:lnSpc>
+                <a:spcPct val="100000"/>
+              </a:lnSpc>
+              <a:spcAft>
+                <a:spcPts val="200"/>
+              </a:spcAft>
+              <a:defRPr sz="1100">
+                <a:solidFill>
+                  <a:srgbClr val="C9D1D9"/>
+                </a:solidFill>
+                <a:latin typeface="Consolas"/>
+              </a:defRPr>
+            </a:pPr>
+            <a:r>
+              <a:t>│  → B3LYP/6-31G(d,p)                             │</a:t>
+            </a:r>
+          </a:p>
+          <a:p>
+            <a:pPr>
+              <a:lnSpc>
+                <a:spcPct val="100000"/>
+              </a:lnSpc>
+              <a:spcAft>
+                <a:spcPts val="200"/>
+              </a:spcAft>
+              <a:defRPr sz="1100">
+                <a:solidFill>
+                  <a:srgbClr val="C9D1D9"/>
+                </a:solidFill>
+                <a:latin typeface="Consolas"/>
+              </a:defRPr>
+            </a:pPr>
+            <a:r>
+              <a:t>│  → Output: reference frequencies                │</a:t>
+            </a:r>
+          </a:p>
+          <a:p>
+            <a:pPr>
+              <a:lnSpc>
+                <a:spcPct val="100000"/>
+              </a:lnSpc>
+              <a:spcAft>
+                <a:spcPts val="200"/>
+              </a:spcAft>
+              <a:defRPr sz="1100">
+                <a:solidFill>
+                  <a:srgbClr val="58A6FF"/>
+                </a:solidFill>
+                <a:latin typeface="Consolas"/>
+              </a:defRPr>
+            </a:pPr>
+            <a:r>
+              <a:t>└─────────────────────────────────────────────────┘</a:t>
+            </a:r>
+          </a:p>
+          <a:p>
+            <a:pPr>
+              <a:lnSpc>
+                <a:spcPct val="100000"/>
+              </a:lnSpc>
+              <a:spcAft>
+                <a:spcPts val="200"/>
+              </a:spcAft>
+              <a:defRPr sz="1100">
+                <a:solidFill>
+                  <a:srgbClr val="8B949E"/>
+                </a:solidFill>
+                <a:latin typeface="Consolas"/>
+              </a:defRPr>
+            </a:pPr>
+            <a:r>
+              <a:t>    │</a:t>
+            </a:r>
+          </a:p>
+          <a:p>
+            <a:pPr>
+              <a:lnSpc>
+                <a:spcPct val="100000"/>
+              </a:lnSpc>
+              <a:spcAft>
+                <a:spcPts val="200"/>
+              </a:spcAft>
+              <a:defRPr sz="1100">
+                <a:solidFill>
+                  <a:srgbClr val="8B949E"/>
+                </a:solidFill>
+                <a:latin typeface="Consolas"/>
+              </a:defRPr>
+            </a:pPr>
+            <a:r>
+              <a:t>    ▼</a:t>
+            </a:r>
+          </a:p>
+          <a:p>
+            <a:pPr>
+              <a:lnSpc>
+                <a:spcPct val="100000"/>
+              </a:lnSpc>
+              <a:spcAft>
+                <a:spcPts val="200"/>
+              </a:spcAft>
+              <a:defRPr sz="1100">
+                <a:solidFill>
+                  <a:srgbClr val="58A6FF"/>
+                </a:solidFill>
+                <a:latin typeface="Consolas"/>
+              </a:defRPr>
+            </a:pPr>
+            <a:r>
+              <a:t>┌─────────────────────────────────────────────────┐</a:t>
+            </a:r>
+          </a:p>
+          <a:p>
+            <a:pPr>
+              <a:lnSpc>
+                <a:spcPct val="100000"/>
+              </a:lnSpc>
+              <a:spcAft>
+                <a:spcPts val="200"/>
+              </a:spcAft>
+              <a:defRPr sz="1100">
+                <a:solidFill>
+                  <a:srgbClr val="58A6FF"/>
+                </a:solidFill>
+                <a:latin typeface="Consolas"/>
+              </a:defRPr>
+            </a:pPr>
+            <a:r>
+              <a:t>│  Phase 3: ML Frequency Calculations             │</a:t>
+            </a:r>
+          </a:p>
+          <a:p>
+            <a:pPr>
+              <a:lnSpc>
+                <a:spcPct val="100000"/>
+              </a:lnSpc>
+              <a:spcAft>
+                <a:spcPts val="200"/>
+              </a:spcAft>
+              <a:defRPr sz="1100">
+                <a:solidFill>
+                  <a:srgbClr val="C9D1D9"/>
+                </a:solidFill>
+                <a:latin typeface="Consolas"/>
+              </a:defRPr>
+            </a:pPr>
+            <a:r>
+              <a:t>│  → Energy: MACE-MP/MACE-OMOL                    │</a:t>
+            </a:r>
+          </a:p>
+          <a:p>
+            <a:pPr>
+              <a:lnSpc>
+                <a:spcPct val="100000"/>
+              </a:lnSpc>
+              <a:spcAft>
+                <a:spcPts val="200"/>
+              </a:spcAft>
+              <a:defRPr sz="1100">
+                <a:solidFill>
+                  <a:srgbClr val="C9D1D9"/>
+                </a:solidFill>
+                <a:latin typeface="Consolas"/>
+              </a:defRPr>
+            </a:pPr>
+            <a:r>
+              <a:t>│  → Dipole: Espaloma/MACE-ML                     │</a:t>
+            </a:r>
+          </a:p>
+          <a:p>
+            <a:pPr>
+              <a:lnSpc>
+                <a:spcPct val="100000"/>
+              </a:lnSpc>
+              <a:spcAft>
+                <a:spcPts val="200"/>
+              </a:spcAft>
+              <a:defRPr sz="1100">
+                <a:solidFill>
+                  <a:srgbClr val="C9D1D9"/>
+                </a:solidFill>
+                <a:latin typeface="Consolas"/>
+              </a:defRPr>
+            </a:pPr>
+            <a:r>
+              <a:t>│  → ZMQ bridge → Gaussian                        │</a:t>
+            </a:r>
+          </a:p>
+          <a:p>
+            <a:pPr>
+              <a:lnSpc>
+                <a:spcPct val="100000"/>
+              </a:lnSpc>
+              <a:spcAft>
+                <a:spcPts val="200"/>
+              </a:spcAft>
+              <a:defRPr sz="1100">
+                <a:solidFill>
+                  <a:srgbClr val="58A6FF"/>
+                </a:solidFill>
+                <a:latin typeface="Consolas"/>
+              </a:defRPr>
+            </a:pPr>
+            <a:r>
+              <a:t>└─────────────────────────────────────────────────┘</a:t>
+            </a:r>
+          </a:p>
+          <a:p>
+            <a:pPr>
+              <a:lnSpc>
+                <a:spcPct val="100000"/>
+              </a:lnSpc>
+              <a:spcAft>
+                <a:spcPts val="200"/>
+              </a:spcAft>
+              <a:defRPr sz="1100">
+                <a:solidFill>
+                  <a:srgbClr val="8B949E"/>
+                </a:solidFill>
+                <a:latin typeface="Consolas"/>
+              </a:defRPr>
+            </a:pPr>
+            <a:r>
+              <a:t>    │</a:t>
+            </a:r>
+          </a:p>
+          <a:p>
+            <a:pPr>
+              <a:lnSpc>
+                <a:spcPct val="100000"/>
+              </a:lnSpc>
+              <a:spcAft>
+                <a:spcPts val="200"/>
+              </a:spcAft>
+              <a:defRPr sz="1100">
+                <a:solidFill>
+                  <a:srgbClr val="8B949E"/>
+                </a:solidFill>
+                <a:latin typeface="Consolas"/>
+              </a:defRPr>
+            </a:pPr>
+            <a:r>
+              <a:t>    ▼</a:t>
+            </a:r>
+          </a:p>
+          <a:p>
+            <a:pPr>
+              <a:lnSpc>
+                <a:spcPct val="100000"/>
+              </a:lnSpc>
+              <a:spcAft>
+                <a:spcPts val="200"/>
+              </a:spcAft>
+              <a:defRPr sz="1100">
+                <a:solidFill>
+                  <a:srgbClr val="58A6FF"/>
+                </a:solidFill>
+                <a:latin typeface="Consolas"/>
+              </a:defRPr>
+            </a:pPr>
+            <a:r>
+              <a:t>┌─────────────────────────────────────────────────┐</a:t>
+            </a:r>
+          </a:p>
+          <a:p>
+            <a:pPr>
+              <a:lnSpc>
+                <a:spcPct val="100000"/>
+              </a:lnSpc>
+              <a:spcAft>
+                <a:spcPts val="200"/>
+              </a:spcAft>
+              <a:defRPr sz="1100">
+                <a:solidFill>
+                  <a:srgbClr val="58A6FF"/>
+                </a:solidFill>
+                <a:latin typeface="Consolas"/>
+              </a:defRPr>
+            </a:pPr>
+            <a:r>
+              <a:t>│  Phase 4: Analysis &amp; Comparison                 │</a:t>
+            </a:r>
+          </a:p>
+          <a:p>
+            <a:pPr>
+              <a:lnSpc>
+                <a:spcPct val="100000"/>
+              </a:lnSpc>
+              <a:spcAft>
+                <a:spcPts val="200"/>
+              </a:spcAft>
+              <a:defRPr sz="1100">
+                <a:solidFill>
+                  <a:srgbClr val="C9D1D9"/>
+                </a:solidFill>
+                <a:latin typeface="Consolas"/>
+              </a:defRPr>
+            </a:pPr>
+            <a:r>
+              <a:t>│  → Statistics: MAE, RMSE, R²                    │</a:t>
+            </a:r>
+          </a:p>
+          <a:p>
+            <a:pPr>
+              <a:lnSpc>
+                <a:spcPct val="100000"/>
+              </a:lnSpc>
+              <a:spcAft>
+                <a:spcPts val="200"/>
+              </a:spcAft>
+              <a:defRPr sz="1100">
+                <a:solidFill>
+                  <a:srgbClr val="C9D1D9"/>
+                </a:solidFill>
+                <a:latin typeface="Consolas"/>
+              </a:defRPr>
+            </a:pPr>
+            <a:r>
+              <a:t>│  → Plots: regression, spectra                   │</a:t>
+            </a:r>
+          </a:p>
+          <a:p>
+            <a:pPr>
+              <a:lnSpc>
+                <a:spcPct val="100000"/>
+              </a:lnSpc>
+              <a:spcAft>
+                <a:spcPts val="200"/>
+              </a:spcAft>
+              <a:defRPr sz="1100">
+                <a:solidFill>
+                  <a:srgbClr val="C9D1D9"/>
+                </a:solidFill>
+                <a:latin typeface="Consolas"/>
+              </a:defRPr>
+            </a:pPr>
+            <a:r>
+              <a:t>│  → Output: HTML report                          │</a:t>
+            </a:r>
+          </a:p>
+          <a:p>
+            <a:pPr>
+              <a:lnSpc>
+                <a:spcPct val="100000"/>
+              </a:lnSpc>
+              <a:spcAft>
+                <a:spcPts val="200"/>
+              </a:spcAft>
+              <a:defRPr sz="1100">
+                <a:solidFill>
+                  <a:srgbClr val="58A6FF"/>
+                </a:solidFill>
+                <a:latin typeface="Consolas"/>
+              </a:defRPr>
+            </a:pPr>
+            <a:r>
+              <a:t>└─────────────────────────────────────────────────┘</a:t>
             </a:r>
           </a:p>
         </p:txBody>

</xml_diff>